<commit_message>
docs: finalize LatinTech submission artifacts
</commit_message>
<xml_diff>
--- a/Projeto_Final_Artefatos/InsurMinds_Projeto_Final.pptx
+++ b/Projeto_Final_Artefatos/InsurMinds_Projeto_Final.pptx
@@ -3316,7 +3316,7 @@
             <a:pPr algn="l">
               <a:defRPr sz="1700" b="0">
                 <a:solidFill>
-                  <a:srgbClr val="18A6A6"/>
+                  <a:srgbClr val="18C2F2"/>
                 </a:solidFill>
                 <a:latin typeface="Aptos"/>
               </a:defRPr>
@@ -3342,7 +3342,7 @@
             <a:avLst/>
           </a:prstGeom>
           <a:solidFill>
-            <a:srgbClr val="18A6A6"/>
+            <a:srgbClr val="18C2F2"/>
           </a:solidFill>
           <a:ln>
             <a:noFill/>
@@ -3414,8 +3414,8 @@
         </p:nvSpPr>
         <p:spPr>
           <a:xfrm>
-            <a:off x="640080" y="6172200"/>
-            <a:ext cx="5486400" cy="274320"/>
+            <a:off x="640080" y="6108192"/>
+            <a:ext cx="10789920" cy="320040"/>
           </a:xfrm>
           <a:prstGeom prst="rect">
             <a:avLst/>
@@ -3429,7 +3429,7 @@
           <a:lstStyle/>
           <a:p>
             <a:pPr algn="l">
-              <a:defRPr sz="1000" b="1">
+              <a:defRPr sz="900" b="1">
                 <a:solidFill>
                   <a:srgbClr val="FFFFFF"/>
                 </a:solidFill>
@@ -3437,7 +3437,7 @@
               </a:defRPr>
             </a:pPr>
             <a:r>
-              <a:t>EQUIPE: PREENCHER NOMES</a:t>
+              <a:t>LATINTECH · Fábio Castro · Lucas Godois · Pedro Campos · Rogério Sousa · Fernando Gonçalves</a:t>
             </a:r>
           </a:p>
         </p:txBody>
@@ -3493,7 +3493,7 @@
             <a:pPr algn="l">
               <a:defRPr sz="1000" b="1">
                 <a:solidFill>
-                  <a:srgbClr val="18A6A6"/>
+                  <a:srgbClr val="18C2F2"/>
                 </a:solidFill>
                 <a:latin typeface="Aptos"/>
               </a:defRPr>
@@ -3619,9 +3619,33 @@
           </a:p>
         </p:txBody>
       </p:sp>
-      <p:sp>
-        <p:nvSpPr>
-          <p:cNvPr id="6" name="Rounded Rectangle 5"/>
+      <p:pic>
+        <p:nvPicPr>
+          <p:cNvPr id="6" name="Picture 5" descr="logo-latin-re.png"/>
+          <p:cNvPicPr>
+            <a:picLocks noChangeAspect="1"/>
+          </p:cNvPicPr>
+          <p:nvPr/>
+        </p:nvPicPr>
+        <p:blipFill>
+          <a:blip r:embed="rId2"/>
+          <a:stretch>
+            <a:fillRect/>
+          </a:stretch>
+        </p:blipFill>
+        <p:spPr>
+          <a:xfrm>
+            <a:off x="10104120" y="118872"/>
+            <a:ext cx="868680" cy="539411"/>
+          </a:xfrm>
+          <a:prstGeom prst="rect">
+            <a:avLst/>
+          </a:prstGeom>
+        </p:spPr>
+      </p:pic>
+      <p:sp>
+        <p:nvSpPr>
+          <p:cNvPr id="7" name="Rounded Rectangle 6"/>
           <p:cNvSpPr/>
           <p:nvPr/>
         </p:nvSpPr>
@@ -3666,7 +3690,7 @@
       </p:sp>
       <p:sp>
         <p:nvSpPr>
-          <p:cNvPr id="7" name="Rectangle 6"/>
+          <p:cNvPr id="8" name="Rectangle 7"/>
           <p:cNvSpPr/>
           <p:nvPr/>
         </p:nvSpPr>
@@ -3709,7 +3733,7 @@
       </p:sp>
       <p:sp>
         <p:nvSpPr>
-          <p:cNvPr id="8" name="TextBox 7"/>
+          <p:cNvPr id="9" name="TextBox 8"/>
           <p:cNvSpPr txBox="1"/>
           <p:nvPr/>
         </p:nvSpPr>
@@ -3745,7 +3769,7 @@
       </p:sp>
       <p:sp>
         <p:nvSpPr>
-          <p:cNvPr id="9" name="TextBox 8"/>
+          <p:cNvPr id="10" name="TextBox 9"/>
           <p:cNvSpPr txBox="1"/>
           <p:nvPr/>
         </p:nvSpPr>
@@ -3781,7 +3805,7 @@
       </p:sp>
       <p:sp>
         <p:nvSpPr>
-          <p:cNvPr id="10" name="TextBox 9"/>
+          <p:cNvPr id="11" name="TextBox 10"/>
           <p:cNvSpPr txBox="1"/>
           <p:nvPr/>
         </p:nvSpPr>
@@ -3817,7 +3841,7 @@
       </p:sp>
       <p:sp>
         <p:nvSpPr>
-          <p:cNvPr id="11" name="Rounded Rectangle 10"/>
+          <p:cNvPr id="12" name="Rounded Rectangle 11"/>
           <p:cNvSpPr/>
           <p:nvPr/>
         </p:nvSpPr>
@@ -3862,7 +3886,7 @@
       </p:sp>
       <p:sp>
         <p:nvSpPr>
-          <p:cNvPr id="12" name="Rectangle 11"/>
+          <p:cNvPr id="13" name="Rectangle 12"/>
           <p:cNvSpPr/>
           <p:nvPr/>
         </p:nvSpPr>
@@ -3905,7 +3929,7 @@
       </p:sp>
       <p:sp>
         <p:nvSpPr>
-          <p:cNvPr id="13" name="TextBox 12"/>
+          <p:cNvPr id="14" name="TextBox 13"/>
           <p:cNvSpPr txBox="1"/>
           <p:nvPr/>
         </p:nvSpPr>
@@ -3941,7 +3965,7 @@
       </p:sp>
       <p:sp>
         <p:nvSpPr>
-          <p:cNvPr id="14" name="TextBox 13"/>
+          <p:cNvPr id="15" name="TextBox 14"/>
           <p:cNvSpPr txBox="1"/>
           <p:nvPr/>
         </p:nvSpPr>
@@ -3977,7 +4001,7 @@
       </p:sp>
       <p:sp>
         <p:nvSpPr>
-          <p:cNvPr id="15" name="TextBox 14"/>
+          <p:cNvPr id="16" name="TextBox 15"/>
           <p:cNvSpPr txBox="1"/>
           <p:nvPr/>
         </p:nvSpPr>
@@ -4013,7 +4037,7 @@
       </p:sp>
       <p:sp>
         <p:nvSpPr>
-          <p:cNvPr id="16" name="Rounded Rectangle 15"/>
+          <p:cNvPr id="17" name="Rounded Rectangle 16"/>
           <p:cNvSpPr/>
           <p:nvPr/>
         </p:nvSpPr>
@@ -4058,7 +4082,7 @@
       </p:sp>
       <p:sp>
         <p:nvSpPr>
-          <p:cNvPr id="17" name="Rectangle 16"/>
+          <p:cNvPr id="18" name="Rectangle 17"/>
           <p:cNvSpPr/>
           <p:nvPr/>
         </p:nvSpPr>
@@ -4101,7 +4125,7 @@
       </p:sp>
       <p:sp>
         <p:nvSpPr>
-          <p:cNvPr id="18" name="TextBox 17"/>
+          <p:cNvPr id="19" name="TextBox 18"/>
           <p:cNvSpPr txBox="1"/>
           <p:nvPr/>
         </p:nvSpPr>
@@ -4137,7 +4161,7 @@
       </p:sp>
       <p:sp>
         <p:nvSpPr>
-          <p:cNvPr id="19" name="TextBox 18"/>
+          <p:cNvPr id="20" name="TextBox 19"/>
           <p:cNvSpPr txBox="1"/>
           <p:nvPr/>
         </p:nvSpPr>
@@ -4173,7 +4197,7 @@
       </p:sp>
       <p:sp>
         <p:nvSpPr>
-          <p:cNvPr id="20" name="TextBox 19"/>
+          <p:cNvPr id="21" name="TextBox 20"/>
           <p:cNvSpPr txBox="1"/>
           <p:nvPr/>
         </p:nvSpPr>
@@ -4209,7 +4233,7 @@
       </p:sp>
       <p:sp>
         <p:nvSpPr>
-          <p:cNvPr id="21" name="TextBox 20"/>
+          <p:cNvPr id="22" name="TextBox 21"/>
           <p:cNvSpPr txBox="1"/>
           <p:nvPr/>
         </p:nvSpPr>
@@ -4294,7 +4318,7 @@
             <a:pPr algn="l">
               <a:defRPr sz="1000" b="1">
                 <a:solidFill>
-                  <a:srgbClr val="18A6A6"/>
+                  <a:srgbClr val="18C2F2"/>
                 </a:solidFill>
                 <a:latin typeface="Aptos"/>
               </a:defRPr>
@@ -4420,9 +4444,33 @@
           </a:p>
         </p:txBody>
       </p:sp>
-      <p:sp>
-        <p:nvSpPr>
-          <p:cNvPr id="6" name="Oval 5"/>
+      <p:pic>
+        <p:nvPicPr>
+          <p:cNvPr id="6" name="Picture 5" descr="logo-latin-re.png"/>
+          <p:cNvPicPr>
+            <a:picLocks noChangeAspect="1"/>
+          </p:cNvPicPr>
+          <p:nvPr/>
+        </p:nvPicPr>
+        <p:blipFill>
+          <a:blip r:embed="rId2"/>
+          <a:stretch>
+            <a:fillRect/>
+          </a:stretch>
+        </p:blipFill>
+        <p:spPr>
+          <a:xfrm>
+            <a:off x="10104120" y="118872"/>
+            <a:ext cx="868680" cy="539411"/>
+          </a:xfrm>
+          <a:prstGeom prst="rect">
+            <a:avLst/>
+          </a:prstGeom>
+        </p:spPr>
+      </p:pic>
+      <p:sp>
+        <p:nvSpPr>
+          <p:cNvPr id="7" name="Oval 6"/>
           <p:cNvSpPr/>
           <p:nvPr/>
         </p:nvSpPr>
@@ -4435,7 +4483,7 @@
             <a:avLst/>
           </a:prstGeom>
           <a:solidFill>
-            <a:srgbClr val="18A6A6"/>
+            <a:srgbClr val="18C2F2"/>
           </a:solidFill>
           <a:ln>
             <a:noFill/>
@@ -4465,7 +4513,7 @@
       </p:sp>
       <p:sp>
         <p:nvSpPr>
-          <p:cNvPr id="7" name="TextBox 6"/>
+          <p:cNvPr id="8" name="TextBox 7"/>
           <p:cNvSpPr txBox="1"/>
           <p:nvPr/>
         </p:nvSpPr>
@@ -4501,7 +4549,7 @@
       </p:sp>
       <p:sp>
         <p:nvSpPr>
-          <p:cNvPr id="8" name="TextBox 7"/>
+          <p:cNvPr id="9" name="TextBox 8"/>
           <p:cNvSpPr txBox="1"/>
           <p:nvPr/>
         </p:nvSpPr>
@@ -4537,7 +4585,7 @@
       </p:sp>
       <p:sp>
         <p:nvSpPr>
-          <p:cNvPr id="9" name="TextBox 8"/>
+          <p:cNvPr id="10" name="TextBox 9"/>
           <p:cNvSpPr txBox="1"/>
           <p:nvPr/>
         </p:nvSpPr>
@@ -4573,7 +4621,7 @@
       </p:sp>
       <p:sp>
         <p:nvSpPr>
-          <p:cNvPr id="10" name="Rectangle 9"/>
+          <p:cNvPr id="11" name="Rectangle 10"/>
           <p:cNvSpPr/>
           <p:nvPr/>
         </p:nvSpPr>
@@ -4616,7 +4664,7 @@
       </p:sp>
       <p:sp>
         <p:nvSpPr>
-          <p:cNvPr id="11" name="Oval 10"/>
+          <p:cNvPr id="12" name="Oval 11"/>
           <p:cNvSpPr/>
           <p:nvPr/>
         </p:nvSpPr>
@@ -4629,7 +4677,7 @@
             <a:avLst/>
           </a:prstGeom>
           <a:solidFill>
-            <a:srgbClr val="18A6A6"/>
+            <a:srgbClr val="18C2F2"/>
           </a:solidFill>
           <a:ln>
             <a:noFill/>
@@ -4659,7 +4707,7 @@
       </p:sp>
       <p:sp>
         <p:nvSpPr>
-          <p:cNvPr id="12" name="TextBox 11"/>
+          <p:cNvPr id="13" name="TextBox 12"/>
           <p:cNvSpPr txBox="1"/>
           <p:nvPr/>
         </p:nvSpPr>
@@ -4695,7 +4743,7 @@
       </p:sp>
       <p:sp>
         <p:nvSpPr>
-          <p:cNvPr id="13" name="TextBox 12"/>
+          <p:cNvPr id="14" name="TextBox 13"/>
           <p:cNvSpPr txBox="1"/>
           <p:nvPr/>
         </p:nvSpPr>
@@ -4731,7 +4779,7 @@
       </p:sp>
       <p:sp>
         <p:nvSpPr>
-          <p:cNvPr id="14" name="TextBox 13"/>
+          <p:cNvPr id="15" name="TextBox 14"/>
           <p:cNvSpPr txBox="1"/>
           <p:nvPr/>
         </p:nvSpPr>
@@ -4767,7 +4815,7 @@
       </p:sp>
       <p:sp>
         <p:nvSpPr>
-          <p:cNvPr id="15" name="Rectangle 14"/>
+          <p:cNvPr id="16" name="Rectangle 15"/>
           <p:cNvSpPr/>
           <p:nvPr/>
         </p:nvSpPr>
@@ -4810,7 +4858,7 @@
       </p:sp>
       <p:sp>
         <p:nvSpPr>
-          <p:cNvPr id="16" name="Oval 15"/>
+          <p:cNvPr id="17" name="Oval 16"/>
           <p:cNvSpPr/>
           <p:nvPr/>
         </p:nvSpPr>
@@ -4823,7 +4871,7 @@
             <a:avLst/>
           </a:prstGeom>
           <a:solidFill>
-            <a:srgbClr val="18A6A6"/>
+            <a:srgbClr val="18C2F2"/>
           </a:solidFill>
           <a:ln>
             <a:noFill/>
@@ -4853,7 +4901,7 @@
       </p:sp>
       <p:sp>
         <p:nvSpPr>
-          <p:cNvPr id="17" name="TextBox 16"/>
+          <p:cNvPr id="18" name="TextBox 17"/>
           <p:cNvSpPr txBox="1"/>
           <p:nvPr/>
         </p:nvSpPr>
@@ -4889,7 +4937,7 @@
       </p:sp>
       <p:sp>
         <p:nvSpPr>
-          <p:cNvPr id="18" name="TextBox 17"/>
+          <p:cNvPr id="19" name="TextBox 18"/>
           <p:cNvSpPr txBox="1"/>
           <p:nvPr/>
         </p:nvSpPr>
@@ -4925,7 +4973,7 @@
       </p:sp>
       <p:sp>
         <p:nvSpPr>
-          <p:cNvPr id="19" name="TextBox 18"/>
+          <p:cNvPr id="20" name="TextBox 19"/>
           <p:cNvSpPr txBox="1"/>
           <p:nvPr/>
         </p:nvSpPr>
@@ -4961,7 +5009,7 @@
       </p:sp>
       <p:sp>
         <p:nvSpPr>
-          <p:cNvPr id="20" name="Rectangle 19"/>
+          <p:cNvPr id="21" name="Rectangle 20"/>
           <p:cNvSpPr/>
           <p:nvPr/>
         </p:nvSpPr>
@@ -5004,7 +5052,7 @@
       </p:sp>
       <p:sp>
         <p:nvSpPr>
-          <p:cNvPr id="21" name="Oval 20"/>
+          <p:cNvPr id="22" name="Oval 21"/>
           <p:cNvSpPr/>
           <p:nvPr/>
         </p:nvSpPr>
@@ -5017,7 +5065,7 @@
             <a:avLst/>
           </a:prstGeom>
           <a:solidFill>
-            <a:srgbClr val="18A6A6"/>
+            <a:srgbClr val="18C2F2"/>
           </a:solidFill>
           <a:ln>
             <a:noFill/>
@@ -5047,7 +5095,7 @@
       </p:sp>
       <p:sp>
         <p:nvSpPr>
-          <p:cNvPr id="22" name="TextBox 21"/>
+          <p:cNvPr id="23" name="TextBox 22"/>
           <p:cNvSpPr txBox="1"/>
           <p:nvPr/>
         </p:nvSpPr>
@@ -5083,7 +5131,7 @@
       </p:sp>
       <p:sp>
         <p:nvSpPr>
-          <p:cNvPr id="23" name="TextBox 22"/>
+          <p:cNvPr id="24" name="TextBox 23"/>
           <p:cNvSpPr txBox="1"/>
           <p:nvPr/>
         </p:nvSpPr>
@@ -5119,7 +5167,7 @@
       </p:sp>
       <p:sp>
         <p:nvSpPr>
-          <p:cNvPr id="24" name="TextBox 23"/>
+          <p:cNvPr id="25" name="TextBox 24"/>
           <p:cNvSpPr txBox="1"/>
           <p:nvPr/>
         </p:nvSpPr>
@@ -5155,7 +5203,7 @@
       </p:sp>
       <p:sp>
         <p:nvSpPr>
-          <p:cNvPr id="25" name="Rectangle 24"/>
+          <p:cNvPr id="26" name="Rectangle 25"/>
           <p:cNvSpPr/>
           <p:nvPr/>
         </p:nvSpPr>
@@ -5198,7 +5246,7 @@
       </p:sp>
       <p:sp>
         <p:nvSpPr>
-          <p:cNvPr id="26" name="Oval 25"/>
+          <p:cNvPr id="27" name="Oval 26"/>
           <p:cNvSpPr/>
           <p:nvPr/>
         </p:nvSpPr>
@@ -5211,7 +5259,7 @@
             <a:avLst/>
           </a:prstGeom>
           <a:solidFill>
-            <a:srgbClr val="18A6A6"/>
+            <a:srgbClr val="18C2F2"/>
           </a:solidFill>
           <a:ln>
             <a:noFill/>
@@ -5241,7 +5289,7 @@
       </p:sp>
       <p:sp>
         <p:nvSpPr>
-          <p:cNvPr id="27" name="TextBox 26"/>
+          <p:cNvPr id="28" name="TextBox 27"/>
           <p:cNvSpPr txBox="1"/>
           <p:nvPr/>
         </p:nvSpPr>
@@ -5277,7 +5325,7 @@
       </p:sp>
       <p:sp>
         <p:nvSpPr>
-          <p:cNvPr id="28" name="TextBox 27"/>
+          <p:cNvPr id="29" name="TextBox 28"/>
           <p:cNvSpPr txBox="1"/>
           <p:nvPr/>
         </p:nvSpPr>
@@ -5313,7 +5361,7 @@
       </p:sp>
       <p:sp>
         <p:nvSpPr>
-          <p:cNvPr id="29" name="TextBox 28"/>
+          <p:cNvPr id="30" name="TextBox 29"/>
           <p:cNvSpPr txBox="1"/>
           <p:nvPr/>
         </p:nvSpPr>
@@ -5349,7 +5397,7 @@
       </p:sp>
       <p:sp>
         <p:nvSpPr>
-          <p:cNvPr id="30" name="Rectangle 29"/>
+          <p:cNvPr id="31" name="Rectangle 30"/>
           <p:cNvSpPr/>
           <p:nvPr/>
         </p:nvSpPr>
@@ -5392,7 +5440,7 @@
       </p:sp>
       <p:sp>
         <p:nvSpPr>
-          <p:cNvPr id="31" name="Oval 30"/>
+          <p:cNvPr id="32" name="Oval 31"/>
           <p:cNvSpPr/>
           <p:nvPr/>
         </p:nvSpPr>
@@ -5405,7 +5453,7 @@
             <a:avLst/>
           </a:prstGeom>
           <a:solidFill>
-            <a:srgbClr val="18A6A6"/>
+            <a:srgbClr val="18C2F2"/>
           </a:solidFill>
           <a:ln>
             <a:noFill/>
@@ -5435,7 +5483,7 @@
       </p:sp>
       <p:sp>
         <p:nvSpPr>
-          <p:cNvPr id="32" name="TextBox 31"/>
+          <p:cNvPr id="33" name="TextBox 32"/>
           <p:cNvSpPr txBox="1"/>
           <p:nvPr/>
         </p:nvSpPr>
@@ -5471,7 +5519,7 @@
       </p:sp>
       <p:sp>
         <p:nvSpPr>
-          <p:cNvPr id="33" name="TextBox 32"/>
+          <p:cNvPr id="34" name="TextBox 33"/>
           <p:cNvSpPr txBox="1"/>
           <p:nvPr/>
         </p:nvSpPr>
@@ -5507,7 +5555,7 @@
       </p:sp>
       <p:sp>
         <p:nvSpPr>
-          <p:cNvPr id="34" name="TextBox 33"/>
+          <p:cNvPr id="35" name="TextBox 34"/>
           <p:cNvSpPr txBox="1"/>
           <p:nvPr/>
         </p:nvSpPr>
@@ -5543,7 +5591,7 @@
       </p:sp>
       <p:sp>
         <p:nvSpPr>
-          <p:cNvPr id="35" name="TextBox 34"/>
+          <p:cNvPr id="36" name="TextBox 35"/>
           <p:cNvSpPr txBox="1"/>
           <p:nvPr/>
         </p:nvSpPr>
@@ -5628,7 +5676,7 @@
             <a:pPr algn="l">
               <a:defRPr sz="1000" b="1">
                 <a:solidFill>
-                  <a:srgbClr val="18A6A6"/>
+                  <a:srgbClr val="18C2F2"/>
                 </a:solidFill>
                 <a:latin typeface="Aptos"/>
               </a:defRPr>
@@ -5754,9 +5802,33 @@
           </a:p>
         </p:txBody>
       </p:sp>
-      <p:sp>
-        <p:nvSpPr>
-          <p:cNvPr id="6" name="Rounded Rectangle 5"/>
+      <p:pic>
+        <p:nvPicPr>
+          <p:cNvPr id="6" name="Picture 5" descr="logo-latin-re.png"/>
+          <p:cNvPicPr>
+            <a:picLocks noChangeAspect="1"/>
+          </p:cNvPicPr>
+          <p:nvPr/>
+        </p:nvPicPr>
+        <p:blipFill>
+          <a:blip r:embed="rId2"/>
+          <a:stretch>
+            <a:fillRect/>
+          </a:stretch>
+        </p:blipFill>
+        <p:spPr>
+          <a:xfrm>
+            <a:off x="10104120" y="118872"/>
+            <a:ext cx="868680" cy="539411"/>
+          </a:xfrm>
+          <a:prstGeom prst="rect">
+            <a:avLst/>
+          </a:prstGeom>
+        </p:spPr>
+      </p:pic>
+      <p:sp>
+        <p:nvSpPr>
+          <p:cNvPr id="7" name="Rounded Rectangle 6"/>
           <p:cNvSpPr/>
           <p:nvPr/>
         </p:nvSpPr>
@@ -5801,7 +5873,7 @@
       </p:sp>
       <p:sp>
         <p:nvSpPr>
-          <p:cNvPr id="7" name="TextBox 6"/>
+          <p:cNvPr id="8" name="TextBox 7"/>
           <p:cNvSpPr txBox="1"/>
           <p:nvPr/>
         </p:nvSpPr>
@@ -5837,7 +5909,7 @@
       </p:sp>
       <p:sp>
         <p:nvSpPr>
-          <p:cNvPr id="8" name="TextBox 7"/>
+          <p:cNvPr id="9" name="TextBox 8"/>
           <p:cNvSpPr txBox="1"/>
           <p:nvPr/>
         </p:nvSpPr>
@@ -5873,7 +5945,7 @@
       </p:sp>
       <p:sp>
         <p:nvSpPr>
-          <p:cNvPr id="9" name="TextBox 8"/>
+          <p:cNvPr id="10" name="TextBox 9"/>
           <p:cNvSpPr txBox="1"/>
           <p:nvPr/>
         </p:nvSpPr>
@@ -5896,7 +5968,7 @@
             <a:pPr algn="ctr">
               <a:defRPr sz="1600" b="1">
                 <a:solidFill>
-                  <a:srgbClr val="18A6A6"/>
+                  <a:srgbClr val="18C2F2"/>
                 </a:solidFill>
                 <a:latin typeface="Aptos"/>
               </a:defRPr>
@@ -5909,7 +5981,7 @@
       </p:sp>
       <p:sp>
         <p:nvSpPr>
-          <p:cNvPr id="10" name="Rounded Rectangle 9"/>
+          <p:cNvPr id="11" name="Rounded Rectangle 10"/>
           <p:cNvSpPr/>
           <p:nvPr/>
         </p:nvSpPr>
@@ -5954,7 +6026,7 @@
       </p:sp>
       <p:sp>
         <p:nvSpPr>
-          <p:cNvPr id="11" name="TextBox 10"/>
+          <p:cNvPr id="12" name="TextBox 11"/>
           <p:cNvSpPr txBox="1"/>
           <p:nvPr/>
         </p:nvSpPr>
@@ -5990,7 +6062,7 @@
       </p:sp>
       <p:sp>
         <p:nvSpPr>
-          <p:cNvPr id="12" name="TextBox 11"/>
+          <p:cNvPr id="13" name="TextBox 12"/>
           <p:cNvSpPr txBox="1"/>
           <p:nvPr/>
         </p:nvSpPr>
@@ -6026,7 +6098,7 @@
       </p:sp>
       <p:sp>
         <p:nvSpPr>
-          <p:cNvPr id="13" name="TextBox 12"/>
+          <p:cNvPr id="14" name="TextBox 13"/>
           <p:cNvSpPr txBox="1"/>
           <p:nvPr/>
         </p:nvSpPr>
@@ -6049,7 +6121,7 @@
             <a:pPr algn="ctr">
               <a:defRPr sz="1600" b="1">
                 <a:solidFill>
-                  <a:srgbClr val="18A6A6"/>
+                  <a:srgbClr val="18C2F2"/>
                 </a:solidFill>
                 <a:latin typeface="Aptos"/>
               </a:defRPr>
@@ -6062,7 +6134,7 @@
       </p:sp>
       <p:sp>
         <p:nvSpPr>
-          <p:cNvPr id="14" name="Rounded Rectangle 13"/>
+          <p:cNvPr id="15" name="Rounded Rectangle 14"/>
           <p:cNvSpPr/>
           <p:nvPr/>
         </p:nvSpPr>
@@ -6079,7 +6151,7 @@
           </a:solidFill>
           <a:ln>
             <a:solidFill>
-              <a:srgbClr val="18A6A6"/>
+              <a:srgbClr val="18C2F2"/>
             </a:solidFill>
           </a:ln>
         </p:spPr>
@@ -6107,7 +6179,7 @@
       </p:sp>
       <p:sp>
         <p:nvSpPr>
-          <p:cNvPr id="15" name="TextBox 14"/>
+          <p:cNvPr id="16" name="TextBox 15"/>
           <p:cNvSpPr txBox="1"/>
           <p:nvPr/>
         </p:nvSpPr>
@@ -6143,7 +6215,7 @@
       </p:sp>
       <p:sp>
         <p:nvSpPr>
-          <p:cNvPr id="16" name="TextBox 15"/>
+          <p:cNvPr id="17" name="TextBox 16"/>
           <p:cNvSpPr txBox="1"/>
           <p:nvPr/>
         </p:nvSpPr>
@@ -6179,7 +6251,7 @@
       </p:sp>
       <p:sp>
         <p:nvSpPr>
-          <p:cNvPr id="17" name="TextBox 16"/>
+          <p:cNvPr id="18" name="TextBox 17"/>
           <p:cNvSpPr txBox="1"/>
           <p:nvPr/>
         </p:nvSpPr>
@@ -6202,7 +6274,7 @@
             <a:pPr algn="ctr">
               <a:defRPr sz="1600" b="1">
                 <a:solidFill>
-                  <a:srgbClr val="18A6A6"/>
+                  <a:srgbClr val="18C2F2"/>
                 </a:solidFill>
                 <a:latin typeface="Aptos"/>
               </a:defRPr>
@@ -6215,7 +6287,7 @@
       </p:sp>
       <p:sp>
         <p:nvSpPr>
-          <p:cNvPr id="18" name="Rounded Rectangle 17"/>
+          <p:cNvPr id="19" name="Rounded Rectangle 18"/>
           <p:cNvSpPr/>
           <p:nvPr/>
         </p:nvSpPr>
@@ -6260,7 +6332,7 @@
       </p:sp>
       <p:sp>
         <p:nvSpPr>
-          <p:cNvPr id="19" name="TextBox 18"/>
+          <p:cNvPr id="20" name="TextBox 19"/>
           <p:cNvSpPr txBox="1"/>
           <p:nvPr/>
         </p:nvSpPr>
@@ -6296,7 +6368,7 @@
       </p:sp>
       <p:sp>
         <p:nvSpPr>
-          <p:cNvPr id="20" name="TextBox 19"/>
+          <p:cNvPr id="21" name="TextBox 20"/>
           <p:cNvSpPr txBox="1"/>
           <p:nvPr/>
         </p:nvSpPr>
@@ -6332,7 +6404,7 @@
       </p:sp>
       <p:sp>
         <p:nvSpPr>
-          <p:cNvPr id="21" name="TextBox 20"/>
+          <p:cNvPr id="22" name="TextBox 21"/>
           <p:cNvSpPr txBox="1"/>
           <p:nvPr/>
         </p:nvSpPr>
@@ -6355,7 +6427,7 @@
             <a:pPr algn="ctr">
               <a:defRPr sz="1600" b="1">
                 <a:solidFill>
-                  <a:srgbClr val="18A6A6"/>
+                  <a:srgbClr val="18C2F2"/>
                 </a:solidFill>
                 <a:latin typeface="Aptos"/>
               </a:defRPr>
@@ -6368,7 +6440,7 @@
       </p:sp>
       <p:sp>
         <p:nvSpPr>
-          <p:cNvPr id="22" name="Rounded Rectangle 21"/>
+          <p:cNvPr id="23" name="Rounded Rectangle 22"/>
           <p:cNvSpPr/>
           <p:nvPr/>
         </p:nvSpPr>
@@ -6413,7 +6485,7 @@
       </p:sp>
       <p:sp>
         <p:nvSpPr>
-          <p:cNvPr id="23" name="TextBox 22"/>
+          <p:cNvPr id="24" name="TextBox 23"/>
           <p:cNvSpPr txBox="1"/>
           <p:nvPr/>
         </p:nvSpPr>
@@ -6449,7 +6521,7 @@
       </p:sp>
       <p:sp>
         <p:nvSpPr>
-          <p:cNvPr id="24" name="TextBox 23"/>
+          <p:cNvPr id="25" name="TextBox 24"/>
           <p:cNvSpPr txBox="1"/>
           <p:nvPr/>
         </p:nvSpPr>
@@ -6485,7 +6557,7 @@
       </p:sp>
       <p:sp>
         <p:nvSpPr>
-          <p:cNvPr id="25" name="TextBox 24"/>
+          <p:cNvPr id="26" name="TextBox 25"/>
           <p:cNvSpPr txBox="1"/>
           <p:nvPr/>
         </p:nvSpPr>
@@ -6508,7 +6580,7 @@
             <a:pPr algn="ctr">
               <a:defRPr sz="1600" b="1">
                 <a:solidFill>
-                  <a:srgbClr val="18A6A6"/>
+                  <a:srgbClr val="18C2F2"/>
                 </a:solidFill>
                 <a:latin typeface="Aptos"/>
               </a:defRPr>
@@ -6521,7 +6593,7 @@
       </p:sp>
       <p:sp>
         <p:nvSpPr>
-          <p:cNvPr id="26" name="Rounded Rectangle 25"/>
+          <p:cNvPr id="27" name="Rounded Rectangle 26"/>
           <p:cNvSpPr/>
           <p:nvPr/>
         </p:nvSpPr>
@@ -6538,7 +6610,7 @@
           </a:solidFill>
           <a:ln>
             <a:solidFill>
-              <a:srgbClr val="18A6A6"/>
+              <a:srgbClr val="18C2F2"/>
             </a:solidFill>
           </a:ln>
         </p:spPr>
@@ -6566,7 +6638,7 @@
       </p:sp>
       <p:sp>
         <p:nvSpPr>
-          <p:cNvPr id="27" name="TextBox 26"/>
+          <p:cNvPr id="28" name="TextBox 27"/>
           <p:cNvSpPr txBox="1"/>
           <p:nvPr/>
         </p:nvSpPr>
@@ -6602,7 +6674,7 @@
       </p:sp>
       <p:sp>
         <p:nvSpPr>
-          <p:cNvPr id="28" name="TextBox 27"/>
+          <p:cNvPr id="29" name="TextBox 28"/>
           <p:cNvSpPr txBox="1"/>
           <p:nvPr/>
         </p:nvSpPr>
@@ -6638,7 +6710,7 @@
       </p:sp>
       <p:sp>
         <p:nvSpPr>
-          <p:cNvPr id="29" name="Rounded Rectangle 28"/>
+          <p:cNvPr id="30" name="Rounded Rectangle 29"/>
           <p:cNvSpPr/>
           <p:nvPr/>
         </p:nvSpPr>
@@ -6683,7 +6755,7 @@
       </p:sp>
       <p:sp>
         <p:nvSpPr>
-          <p:cNvPr id="30" name="Rectangle 29"/>
+          <p:cNvPr id="31" name="Rectangle 30"/>
           <p:cNvSpPr/>
           <p:nvPr/>
         </p:nvSpPr>
@@ -6696,7 +6768,7 @@
             <a:avLst/>
           </a:prstGeom>
           <a:solidFill>
-            <a:srgbClr val="18A6A6"/>
+            <a:srgbClr val="18C2F2"/>
           </a:solidFill>
           <a:ln>
             <a:noFill/>
@@ -6726,7 +6798,7 @@
       </p:sp>
       <p:sp>
         <p:nvSpPr>
-          <p:cNvPr id="31" name="TextBox 30"/>
+          <p:cNvPr id="32" name="TextBox 31"/>
           <p:cNvSpPr txBox="1"/>
           <p:nvPr/>
         </p:nvSpPr>
@@ -6762,7 +6834,7 @@
       </p:sp>
       <p:sp>
         <p:nvSpPr>
-          <p:cNvPr id="32" name="TextBox 31"/>
+          <p:cNvPr id="33" name="TextBox 32"/>
           <p:cNvSpPr txBox="1"/>
           <p:nvPr/>
         </p:nvSpPr>
@@ -6798,7 +6870,7 @@
       </p:sp>
       <p:sp>
         <p:nvSpPr>
-          <p:cNvPr id="33" name="Rounded Rectangle 32"/>
+          <p:cNvPr id="34" name="Rounded Rectangle 33"/>
           <p:cNvSpPr/>
           <p:nvPr/>
         </p:nvSpPr>
@@ -6843,7 +6915,7 @@
       </p:sp>
       <p:sp>
         <p:nvSpPr>
-          <p:cNvPr id="34" name="Rectangle 33"/>
+          <p:cNvPr id="35" name="Rectangle 34"/>
           <p:cNvSpPr/>
           <p:nvPr/>
         </p:nvSpPr>
@@ -6886,7 +6958,7 @@
       </p:sp>
       <p:sp>
         <p:nvSpPr>
-          <p:cNvPr id="35" name="TextBox 34"/>
+          <p:cNvPr id="36" name="TextBox 35"/>
           <p:cNvSpPr txBox="1"/>
           <p:nvPr/>
         </p:nvSpPr>
@@ -6922,7 +6994,7 @@
       </p:sp>
       <p:sp>
         <p:nvSpPr>
-          <p:cNvPr id="36" name="TextBox 35"/>
+          <p:cNvPr id="37" name="TextBox 36"/>
           <p:cNvSpPr txBox="1"/>
           <p:nvPr/>
         </p:nvSpPr>
@@ -6958,7 +7030,7 @@
       </p:sp>
       <p:sp>
         <p:nvSpPr>
-          <p:cNvPr id="37" name="Rounded Rectangle 36"/>
+          <p:cNvPr id="38" name="Rounded Rectangle 37"/>
           <p:cNvSpPr/>
           <p:nvPr/>
         </p:nvSpPr>
@@ -7003,7 +7075,7 @@
       </p:sp>
       <p:sp>
         <p:nvSpPr>
-          <p:cNvPr id="38" name="Rectangle 37"/>
+          <p:cNvPr id="39" name="Rectangle 38"/>
           <p:cNvSpPr/>
           <p:nvPr/>
         </p:nvSpPr>
@@ -7016,7 +7088,7 @@
             <a:avLst/>
           </a:prstGeom>
           <a:solidFill>
-            <a:srgbClr val="18A6A6"/>
+            <a:srgbClr val="18C2F2"/>
           </a:solidFill>
           <a:ln>
             <a:noFill/>
@@ -7046,7 +7118,7 @@
       </p:sp>
       <p:sp>
         <p:nvSpPr>
-          <p:cNvPr id="39" name="TextBox 38"/>
+          <p:cNvPr id="40" name="TextBox 39"/>
           <p:cNvSpPr txBox="1"/>
           <p:nvPr/>
         </p:nvSpPr>
@@ -7082,7 +7154,7 @@
       </p:sp>
       <p:sp>
         <p:nvSpPr>
-          <p:cNvPr id="40" name="TextBox 39"/>
+          <p:cNvPr id="41" name="TextBox 40"/>
           <p:cNvSpPr txBox="1"/>
           <p:nvPr/>
         </p:nvSpPr>
@@ -7167,7 +7239,7 @@
             <a:pPr algn="l">
               <a:defRPr sz="1000" b="1">
                 <a:solidFill>
-                  <a:srgbClr val="18A6A6"/>
+                  <a:srgbClr val="18C2F2"/>
                 </a:solidFill>
                 <a:latin typeface="Aptos"/>
               </a:defRPr>
@@ -7293,9 +7365,33 @@
           </a:p>
         </p:txBody>
       </p:sp>
-      <p:sp>
-        <p:nvSpPr>
-          <p:cNvPr id="6" name="Rounded Rectangle 5"/>
+      <p:pic>
+        <p:nvPicPr>
+          <p:cNvPr id="6" name="Picture 5" descr="logo-latin-re.png"/>
+          <p:cNvPicPr>
+            <a:picLocks noChangeAspect="1"/>
+          </p:cNvPicPr>
+          <p:nvPr/>
+        </p:nvPicPr>
+        <p:blipFill>
+          <a:blip r:embed="rId2"/>
+          <a:stretch>
+            <a:fillRect/>
+          </a:stretch>
+        </p:blipFill>
+        <p:spPr>
+          <a:xfrm>
+            <a:off x="10104120" y="118872"/>
+            <a:ext cx="868680" cy="539411"/>
+          </a:xfrm>
+          <a:prstGeom prst="rect">
+            <a:avLst/>
+          </a:prstGeom>
+        </p:spPr>
+      </p:pic>
+      <p:sp>
+        <p:nvSpPr>
+          <p:cNvPr id="7" name="Rounded Rectangle 6"/>
           <p:cNvSpPr/>
           <p:nvPr/>
         </p:nvSpPr>
@@ -7340,7 +7436,7 @@
       </p:sp>
       <p:sp>
         <p:nvSpPr>
-          <p:cNvPr id="7" name="Rectangle 6"/>
+          <p:cNvPr id="8" name="Rectangle 7"/>
           <p:cNvSpPr/>
           <p:nvPr/>
         </p:nvSpPr>
@@ -7353,7 +7449,7 @@
             <a:avLst/>
           </a:prstGeom>
           <a:solidFill>
-            <a:srgbClr val="18A6A6"/>
+            <a:srgbClr val="18C2F2"/>
           </a:solidFill>
           <a:ln>
             <a:noFill/>
@@ -7383,7 +7479,7 @@
       </p:sp>
       <p:sp>
         <p:nvSpPr>
-          <p:cNvPr id="8" name="TextBox 7"/>
+          <p:cNvPr id="9" name="TextBox 8"/>
           <p:cNvSpPr txBox="1"/>
           <p:nvPr/>
         </p:nvSpPr>
@@ -7406,7 +7502,7 @@
             <a:pPr algn="l">
               <a:defRPr sz="1700" b="1">
                 <a:solidFill>
-                  <a:srgbClr val="18A6A6"/>
+                  <a:srgbClr val="18C2F2"/>
                 </a:solidFill>
                 <a:latin typeface="Aptos"/>
               </a:defRPr>
@@ -7419,7 +7515,7 @@
       </p:sp>
       <p:sp>
         <p:nvSpPr>
-          <p:cNvPr id="9" name="TextBox 8"/>
+          <p:cNvPr id="10" name="TextBox 9"/>
           <p:cNvSpPr txBox="1"/>
           <p:nvPr/>
         </p:nvSpPr>
@@ -7455,7 +7551,7 @@
       </p:sp>
       <p:sp>
         <p:nvSpPr>
-          <p:cNvPr id="10" name="TextBox 9"/>
+          <p:cNvPr id="11" name="TextBox 10"/>
           <p:cNvSpPr txBox="1"/>
           <p:nvPr/>
         </p:nvSpPr>
@@ -7491,7 +7587,7 @@
       </p:sp>
       <p:sp>
         <p:nvSpPr>
-          <p:cNvPr id="11" name="Rounded Rectangle 10"/>
+          <p:cNvPr id="12" name="Rounded Rectangle 11"/>
           <p:cNvSpPr/>
           <p:nvPr/>
         </p:nvSpPr>
@@ -7536,7 +7632,7 @@
       </p:sp>
       <p:sp>
         <p:nvSpPr>
-          <p:cNvPr id="12" name="Rectangle 11"/>
+          <p:cNvPr id="13" name="Rectangle 12"/>
           <p:cNvSpPr/>
           <p:nvPr/>
         </p:nvSpPr>
@@ -7579,7 +7675,7 @@
       </p:sp>
       <p:sp>
         <p:nvSpPr>
-          <p:cNvPr id="13" name="TextBox 12"/>
+          <p:cNvPr id="14" name="TextBox 13"/>
           <p:cNvSpPr txBox="1"/>
           <p:nvPr/>
         </p:nvSpPr>
@@ -7615,7 +7711,7 @@
       </p:sp>
       <p:sp>
         <p:nvSpPr>
-          <p:cNvPr id="14" name="TextBox 13"/>
+          <p:cNvPr id="15" name="TextBox 14"/>
           <p:cNvSpPr txBox="1"/>
           <p:nvPr/>
         </p:nvSpPr>
@@ -7651,7 +7747,7 @@
       </p:sp>
       <p:sp>
         <p:nvSpPr>
-          <p:cNvPr id="15" name="TextBox 14"/>
+          <p:cNvPr id="16" name="TextBox 15"/>
           <p:cNvSpPr txBox="1"/>
           <p:nvPr/>
         </p:nvSpPr>
@@ -7687,7 +7783,7 @@
       </p:sp>
       <p:sp>
         <p:nvSpPr>
-          <p:cNvPr id="16" name="Rounded Rectangle 15"/>
+          <p:cNvPr id="17" name="Rounded Rectangle 16"/>
           <p:cNvSpPr/>
           <p:nvPr/>
         </p:nvSpPr>
@@ -7732,7 +7828,7 @@
       </p:sp>
       <p:sp>
         <p:nvSpPr>
-          <p:cNvPr id="17" name="Rectangle 16"/>
+          <p:cNvPr id="18" name="Rectangle 17"/>
           <p:cNvSpPr/>
           <p:nvPr/>
         </p:nvSpPr>
@@ -7745,7 +7841,7 @@
             <a:avLst/>
           </a:prstGeom>
           <a:solidFill>
-            <a:srgbClr val="18A6A6"/>
+            <a:srgbClr val="18C2F2"/>
           </a:solidFill>
           <a:ln>
             <a:noFill/>
@@ -7775,7 +7871,7 @@
       </p:sp>
       <p:sp>
         <p:nvSpPr>
-          <p:cNvPr id="18" name="TextBox 17"/>
+          <p:cNvPr id="19" name="TextBox 18"/>
           <p:cNvSpPr txBox="1"/>
           <p:nvPr/>
         </p:nvSpPr>
@@ -7798,7 +7894,7 @@
             <a:pPr algn="l">
               <a:defRPr sz="1700" b="1">
                 <a:solidFill>
-                  <a:srgbClr val="18A6A6"/>
+                  <a:srgbClr val="18C2F2"/>
                 </a:solidFill>
                 <a:latin typeface="Aptos"/>
               </a:defRPr>
@@ -7811,7 +7907,7 @@
       </p:sp>
       <p:sp>
         <p:nvSpPr>
-          <p:cNvPr id="19" name="TextBox 18"/>
+          <p:cNvPr id="20" name="TextBox 19"/>
           <p:cNvSpPr txBox="1"/>
           <p:nvPr/>
         </p:nvSpPr>
@@ -7847,7 +7943,7 @@
       </p:sp>
       <p:sp>
         <p:nvSpPr>
-          <p:cNvPr id="20" name="TextBox 19"/>
+          <p:cNvPr id="21" name="TextBox 20"/>
           <p:cNvSpPr txBox="1"/>
           <p:nvPr/>
         </p:nvSpPr>
@@ -7883,7 +7979,7 @@
       </p:sp>
       <p:sp>
         <p:nvSpPr>
-          <p:cNvPr id="21" name="Rounded Rectangle 20"/>
+          <p:cNvPr id="22" name="Rounded Rectangle 21"/>
           <p:cNvSpPr/>
           <p:nvPr/>
         </p:nvSpPr>
@@ -7928,7 +8024,7 @@
       </p:sp>
       <p:sp>
         <p:nvSpPr>
-          <p:cNvPr id="22" name="Rectangle 21"/>
+          <p:cNvPr id="23" name="Rectangle 22"/>
           <p:cNvSpPr/>
           <p:nvPr/>
         </p:nvSpPr>
@@ -7971,7 +8067,7 @@
       </p:sp>
       <p:sp>
         <p:nvSpPr>
-          <p:cNvPr id="23" name="TextBox 22"/>
+          <p:cNvPr id="24" name="TextBox 23"/>
           <p:cNvSpPr txBox="1"/>
           <p:nvPr/>
         </p:nvSpPr>
@@ -8007,7 +8103,7 @@
       </p:sp>
       <p:sp>
         <p:nvSpPr>
-          <p:cNvPr id="24" name="TextBox 23"/>
+          <p:cNvPr id="25" name="TextBox 24"/>
           <p:cNvSpPr txBox="1"/>
           <p:nvPr/>
         </p:nvSpPr>
@@ -8043,7 +8139,7 @@
       </p:sp>
       <p:sp>
         <p:nvSpPr>
-          <p:cNvPr id="25" name="TextBox 24"/>
+          <p:cNvPr id="26" name="TextBox 25"/>
           <p:cNvSpPr txBox="1"/>
           <p:nvPr/>
         </p:nvSpPr>
@@ -8079,7 +8175,7 @@
       </p:sp>
       <p:sp>
         <p:nvSpPr>
-          <p:cNvPr id="26" name="Rounded Rectangle 25"/>
+          <p:cNvPr id="27" name="Rounded Rectangle 26"/>
           <p:cNvSpPr/>
           <p:nvPr/>
         </p:nvSpPr>
@@ -8124,7 +8220,7 @@
       </p:sp>
       <p:sp>
         <p:nvSpPr>
-          <p:cNvPr id="27" name="Rectangle 26"/>
+          <p:cNvPr id="28" name="Rectangle 27"/>
           <p:cNvSpPr/>
           <p:nvPr/>
         </p:nvSpPr>
@@ -8137,7 +8233,7 @@
             <a:avLst/>
           </a:prstGeom>
           <a:solidFill>
-            <a:srgbClr val="18A6A6"/>
+            <a:srgbClr val="18C2F2"/>
           </a:solidFill>
           <a:ln>
             <a:noFill/>
@@ -8167,7 +8263,7 @@
       </p:sp>
       <p:sp>
         <p:nvSpPr>
-          <p:cNvPr id="28" name="TextBox 27"/>
+          <p:cNvPr id="29" name="TextBox 28"/>
           <p:cNvSpPr txBox="1"/>
           <p:nvPr/>
         </p:nvSpPr>
@@ -8190,7 +8286,7 @@
             <a:pPr algn="l">
               <a:defRPr sz="1700" b="1">
                 <a:solidFill>
-                  <a:srgbClr val="18A6A6"/>
+                  <a:srgbClr val="18C2F2"/>
                 </a:solidFill>
                 <a:latin typeface="Aptos"/>
               </a:defRPr>
@@ -8203,7 +8299,7 @@
       </p:sp>
       <p:sp>
         <p:nvSpPr>
-          <p:cNvPr id="29" name="TextBox 28"/>
+          <p:cNvPr id="30" name="TextBox 29"/>
           <p:cNvSpPr txBox="1"/>
           <p:nvPr/>
         </p:nvSpPr>
@@ -8239,7 +8335,7 @@
       </p:sp>
       <p:sp>
         <p:nvSpPr>
-          <p:cNvPr id="30" name="TextBox 29"/>
+          <p:cNvPr id="31" name="TextBox 30"/>
           <p:cNvSpPr txBox="1"/>
           <p:nvPr/>
         </p:nvSpPr>
@@ -8275,7 +8371,7 @@
       </p:sp>
       <p:sp>
         <p:nvSpPr>
-          <p:cNvPr id="31" name="Rounded Rectangle 30"/>
+          <p:cNvPr id="32" name="Rounded Rectangle 31"/>
           <p:cNvSpPr/>
           <p:nvPr/>
         </p:nvSpPr>
@@ -8320,7 +8416,7 @@
       </p:sp>
       <p:sp>
         <p:nvSpPr>
-          <p:cNvPr id="32" name="Rectangle 31"/>
+          <p:cNvPr id="33" name="Rectangle 32"/>
           <p:cNvSpPr/>
           <p:nvPr/>
         </p:nvSpPr>
@@ -8363,7 +8459,7 @@
       </p:sp>
       <p:sp>
         <p:nvSpPr>
-          <p:cNvPr id="33" name="TextBox 32"/>
+          <p:cNvPr id="34" name="TextBox 33"/>
           <p:cNvSpPr txBox="1"/>
           <p:nvPr/>
         </p:nvSpPr>
@@ -8399,7 +8495,7 @@
       </p:sp>
       <p:sp>
         <p:nvSpPr>
-          <p:cNvPr id="34" name="TextBox 33"/>
+          <p:cNvPr id="35" name="TextBox 34"/>
           <p:cNvSpPr txBox="1"/>
           <p:nvPr/>
         </p:nvSpPr>
@@ -8435,7 +8531,7 @@
       </p:sp>
       <p:sp>
         <p:nvSpPr>
-          <p:cNvPr id="35" name="TextBox 34"/>
+          <p:cNvPr id="36" name="TextBox 35"/>
           <p:cNvSpPr txBox="1"/>
           <p:nvPr/>
         </p:nvSpPr>
@@ -8520,7 +8616,7 @@
             <a:pPr algn="l">
               <a:defRPr sz="1000" b="1">
                 <a:solidFill>
-                  <a:srgbClr val="18A6A6"/>
+                  <a:srgbClr val="18C2F2"/>
                 </a:solidFill>
                 <a:latin typeface="Aptos"/>
               </a:defRPr>
@@ -8646,9 +8742,33 @@
           </a:p>
         </p:txBody>
       </p:sp>
-      <p:sp>
-        <p:nvSpPr>
-          <p:cNvPr id="6" name="Oval 5"/>
+      <p:pic>
+        <p:nvPicPr>
+          <p:cNvPr id="6" name="Picture 5" descr="logo-latin-re.png"/>
+          <p:cNvPicPr>
+            <a:picLocks noChangeAspect="1"/>
+          </p:cNvPicPr>
+          <p:nvPr/>
+        </p:nvPicPr>
+        <p:blipFill>
+          <a:blip r:embed="rId2"/>
+          <a:stretch>
+            <a:fillRect/>
+          </a:stretch>
+        </p:blipFill>
+        <p:spPr>
+          <a:xfrm>
+            <a:off x="10104120" y="118872"/>
+            <a:ext cx="868680" cy="539411"/>
+          </a:xfrm>
+          <a:prstGeom prst="rect">
+            <a:avLst/>
+          </a:prstGeom>
+        </p:spPr>
+      </p:pic>
+      <p:sp>
+        <p:nvSpPr>
+          <p:cNvPr id="7" name="Oval 6"/>
           <p:cNvSpPr/>
           <p:nvPr/>
         </p:nvSpPr>
@@ -8661,7 +8781,7 @@
             <a:avLst/>
           </a:prstGeom>
           <a:solidFill>
-            <a:srgbClr val="18A6A6"/>
+            <a:srgbClr val="18C2F2"/>
           </a:solidFill>
           <a:ln>
             <a:noFill/>
@@ -8691,7 +8811,7 @@
       </p:sp>
       <p:sp>
         <p:nvSpPr>
-          <p:cNvPr id="7" name="TextBox 6"/>
+          <p:cNvPr id="8" name="TextBox 7"/>
           <p:cNvSpPr txBox="1"/>
           <p:nvPr/>
         </p:nvSpPr>
@@ -8727,7 +8847,7 @@
       </p:sp>
       <p:sp>
         <p:nvSpPr>
-          <p:cNvPr id="8" name="TextBox 7"/>
+          <p:cNvPr id="9" name="TextBox 8"/>
           <p:cNvSpPr txBox="1"/>
           <p:nvPr/>
         </p:nvSpPr>
@@ -8763,7 +8883,7 @@
       </p:sp>
       <p:sp>
         <p:nvSpPr>
-          <p:cNvPr id="9" name="Oval 8"/>
+          <p:cNvPr id="10" name="Oval 9"/>
           <p:cNvSpPr/>
           <p:nvPr/>
         </p:nvSpPr>
@@ -8806,7 +8926,7 @@
       </p:sp>
       <p:sp>
         <p:nvSpPr>
-          <p:cNvPr id="10" name="TextBox 9"/>
+          <p:cNvPr id="11" name="TextBox 10"/>
           <p:cNvSpPr txBox="1"/>
           <p:nvPr/>
         </p:nvSpPr>
@@ -8842,7 +8962,7 @@
       </p:sp>
       <p:sp>
         <p:nvSpPr>
-          <p:cNvPr id="11" name="TextBox 10"/>
+          <p:cNvPr id="12" name="TextBox 11"/>
           <p:cNvSpPr txBox="1"/>
           <p:nvPr/>
         </p:nvSpPr>
@@ -8878,7 +8998,7 @@
       </p:sp>
       <p:sp>
         <p:nvSpPr>
-          <p:cNvPr id="12" name="Oval 11"/>
+          <p:cNvPr id="13" name="Oval 12"/>
           <p:cNvSpPr/>
           <p:nvPr/>
         </p:nvSpPr>
@@ -8891,7 +9011,7 @@
             <a:avLst/>
           </a:prstGeom>
           <a:solidFill>
-            <a:srgbClr val="18A6A6"/>
+            <a:srgbClr val="18C2F2"/>
           </a:solidFill>
           <a:ln>
             <a:noFill/>
@@ -8921,7 +9041,7 @@
       </p:sp>
       <p:sp>
         <p:nvSpPr>
-          <p:cNvPr id="13" name="TextBox 12"/>
+          <p:cNvPr id="14" name="TextBox 13"/>
           <p:cNvSpPr txBox="1"/>
           <p:nvPr/>
         </p:nvSpPr>
@@ -8957,7 +9077,7 @@
       </p:sp>
       <p:sp>
         <p:nvSpPr>
-          <p:cNvPr id="14" name="TextBox 13"/>
+          <p:cNvPr id="15" name="TextBox 14"/>
           <p:cNvSpPr txBox="1"/>
           <p:nvPr/>
         </p:nvSpPr>
@@ -8993,7 +9113,7 @@
       </p:sp>
       <p:sp>
         <p:nvSpPr>
-          <p:cNvPr id="15" name="Oval 14"/>
+          <p:cNvPr id="16" name="Oval 15"/>
           <p:cNvSpPr/>
           <p:nvPr/>
         </p:nvSpPr>
@@ -9036,7 +9156,7 @@
       </p:sp>
       <p:sp>
         <p:nvSpPr>
-          <p:cNvPr id="16" name="TextBox 15"/>
+          <p:cNvPr id="17" name="TextBox 16"/>
           <p:cNvSpPr txBox="1"/>
           <p:nvPr/>
         </p:nvSpPr>
@@ -9072,7 +9192,7 @@
       </p:sp>
       <p:sp>
         <p:nvSpPr>
-          <p:cNvPr id="17" name="TextBox 16"/>
+          <p:cNvPr id="18" name="TextBox 17"/>
           <p:cNvSpPr txBox="1"/>
           <p:nvPr/>
         </p:nvSpPr>
@@ -9108,7 +9228,7 @@
       </p:sp>
       <p:sp>
         <p:nvSpPr>
-          <p:cNvPr id="18" name="Oval 17"/>
+          <p:cNvPr id="19" name="Oval 18"/>
           <p:cNvSpPr/>
           <p:nvPr/>
         </p:nvSpPr>
@@ -9121,7 +9241,7 @@
             <a:avLst/>
           </a:prstGeom>
           <a:solidFill>
-            <a:srgbClr val="18A6A6"/>
+            <a:srgbClr val="18C2F2"/>
           </a:solidFill>
           <a:ln>
             <a:noFill/>
@@ -9151,7 +9271,7 @@
       </p:sp>
       <p:sp>
         <p:nvSpPr>
-          <p:cNvPr id="19" name="TextBox 18"/>
+          <p:cNvPr id="20" name="TextBox 19"/>
           <p:cNvSpPr txBox="1"/>
           <p:nvPr/>
         </p:nvSpPr>
@@ -9187,7 +9307,7 @@
       </p:sp>
       <p:sp>
         <p:nvSpPr>
-          <p:cNvPr id="20" name="TextBox 19"/>
+          <p:cNvPr id="21" name="TextBox 20"/>
           <p:cNvSpPr txBox="1"/>
           <p:nvPr/>
         </p:nvSpPr>
@@ -9223,7 +9343,7 @@
       </p:sp>
       <p:sp>
         <p:nvSpPr>
-          <p:cNvPr id="21" name="Oval 20"/>
+          <p:cNvPr id="22" name="Oval 21"/>
           <p:cNvSpPr/>
           <p:nvPr/>
         </p:nvSpPr>
@@ -9266,7 +9386,7 @@
       </p:sp>
       <p:sp>
         <p:nvSpPr>
-          <p:cNvPr id="22" name="TextBox 21"/>
+          <p:cNvPr id="23" name="TextBox 22"/>
           <p:cNvSpPr txBox="1"/>
           <p:nvPr/>
         </p:nvSpPr>
@@ -9302,7 +9422,7 @@
       </p:sp>
       <p:sp>
         <p:nvSpPr>
-          <p:cNvPr id="23" name="TextBox 22"/>
+          <p:cNvPr id="24" name="TextBox 23"/>
           <p:cNvSpPr txBox="1"/>
           <p:nvPr/>
         </p:nvSpPr>
@@ -9387,7 +9507,7 @@
             <a:pPr algn="l">
               <a:defRPr sz="1000" b="1">
                 <a:solidFill>
-                  <a:srgbClr val="18A6A6"/>
+                  <a:srgbClr val="18C2F2"/>
                 </a:solidFill>
                 <a:latin typeface="Aptos"/>
               </a:defRPr>
@@ -9513,9 +9633,33 @@
           </a:p>
         </p:txBody>
       </p:sp>
-      <p:sp>
-        <p:nvSpPr>
-          <p:cNvPr id="6" name="TextBox 5"/>
+      <p:pic>
+        <p:nvPicPr>
+          <p:cNvPr id="6" name="Picture 5" descr="logo-latin-re.png"/>
+          <p:cNvPicPr>
+            <a:picLocks noChangeAspect="1"/>
+          </p:cNvPicPr>
+          <p:nvPr/>
+        </p:nvPicPr>
+        <p:blipFill>
+          <a:blip r:embed="rId2"/>
+          <a:stretch>
+            <a:fillRect/>
+          </a:stretch>
+        </p:blipFill>
+        <p:spPr>
+          <a:xfrm>
+            <a:off x="10104120" y="118872"/>
+            <a:ext cx="868680" cy="539411"/>
+          </a:xfrm>
+          <a:prstGeom prst="rect">
+            <a:avLst/>
+          </a:prstGeom>
+        </p:spPr>
+      </p:pic>
+      <p:sp>
+        <p:nvSpPr>
+          <p:cNvPr id="7" name="TextBox 6"/>
           <p:cNvSpPr txBox="1"/>
           <p:nvPr/>
         </p:nvSpPr>
@@ -9538,7 +9682,7 @@
             <a:pPr algn="ctr">
               <a:defRPr sz="3400" b="1">
                 <a:solidFill>
-                  <a:srgbClr val="18A6A6"/>
+                  <a:srgbClr val="18C2F2"/>
                 </a:solidFill>
                 <a:latin typeface="Aptos"/>
               </a:defRPr>
@@ -9551,7 +9695,7 @@
       </p:sp>
       <p:sp>
         <p:nvSpPr>
-          <p:cNvPr id="7" name="TextBox 6"/>
+          <p:cNvPr id="8" name="TextBox 7"/>
           <p:cNvSpPr txBox="1"/>
           <p:nvPr/>
         </p:nvSpPr>
@@ -9587,7 +9731,7 @@
       </p:sp>
       <p:sp>
         <p:nvSpPr>
-          <p:cNvPr id="8" name="TextBox 7"/>
+          <p:cNvPr id="9" name="TextBox 8"/>
           <p:cNvSpPr txBox="1"/>
           <p:nvPr/>
         </p:nvSpPr>
@@ -9623,7 +9767,7 @@
       </p:sp>
       <p:sp>
         <p:nvSpPr>
-          <p:cNvPr id="9" name="TextBox 8"/>
+          <p:cNvPr id="10" name="TextBox 9"/>
           <p:cNvSpPr txBox="1"/>
           <p:nvPr/>
         </p:nvSpPr>
@@ -9659,7 +9803,7 @@
       </p:sp>
       <p:sp>
         <p:nvSpPr>
-          <p:cNvPr id="10" name="TextBox 9"/>
+          <p:cNvPr id="11" name="TextBox 10"/>
           <p:cNvSpPr txBox="1"/>
           <p:nvPr/>
         </p:nvSpPr>
@@ -9682,20 +9826,20 @@
             <a:pPr algn="ctr">
               <a:defRPr sz="3400" b="1">
                 <a:solidFill>
-                  <a:srgbClr val="18A6A6"/>
-                </a:solidFill>
-                <a:latin typeface="Aptos"/>
-              </a:defRPr>
-            </a:pPr>
-            <a:r>
-              <a:t>9/9</a:t>
-            </a:r>
-          </a:p>
-        </p:txBody>
-      </p:sp>
-      <p:sp>
-        <p:nvSpPr>
-          <p:cNvPr id="11" name="TextBox 10"/>
+                  <a:srgbClr val="18C2F2"/>
+                </a:solidFill>
+                <a:latin typeface="Aptos"/>
+              </a:defRPr>
+            </a:pPr>
+            <a:r>
+              <a:t>14/14</a:t>
+            </a:r>
+          </a:p>
+        </p:txBody>
+      </p:sp>
+      <p:sp>
+        <p:nvSpPr>
+          <p:cNvPr id="12" name="TextBox 11"/>
           <p:cNvSpPr txBox="1"/>
           <p:nvPr/>
         </p:nvSpPr>
@@ -9731,7 +9875,7 @@
       </p:sp>
       <p:sp>
         <p:nvSpPr>
-          <p:cNvPr id="12" name="TextBox 11"/>
+          <p:cNvPr id="13" name="TextBox 12"/>
           <p:cNvSpPr txBox="1"/>
           <p:nvPr/>
         </p:nvSpPr>
@@ -9767,7 +9911,7 @@
       </p:sp>
       <p:sp>
         <p:nvSpPr>
-          <p:cNvPr id="13" name="TextBox 12"/>
+          <p:cNvPr id="14" name="TextBox 13"/>
           <p:cNvSpPr txBox="1"/>
           <p:nvPr/>
         </p:nvSpPr>
@@ -9803,7 +9947,7 @@
       </p:sp>
       <p:sp>
         <p:nvSpPr>
-          <p:cNvPr id="14" name="Rounded Rectangle 13"/>
+          <p:cNvPr id="15" name="Rounded Rectangle 14"/>
           <p:cNvSpPr/>
           <p:nvPr/>
         </p:nvSpPr>
@@ -9848,7 +9992,7 @@
       </p:sp>
       <p:sp>
         <p:nvSpPr>
-          <p:cNvPr id="15" name="Rectangle 14"/>
+          <p:cNvPr id="16" name="Rectangle 15"/>
           <p:cNvSpPr/>
           <p:nvPr/>
         </p:nvSpPr>
@@ -9861,7 +10005,7 @@
             <a:avLst/>
           </a:prstGeom>
           <a:solidFill>
-            <a:srgbClr val="18A6A6"/>
+            <a:srgbClr val="18C2F2"/>
           </a:solidFill>
           <a:ln>
             <a:noFill/>
@@ -9891,7 +10035,7 @@
       </p:sp>
       <p:sp>
         <p:nvSpPr>
-          <p:cNvPr id="16" name="TextBox 15"/>
+          <p:cNvPr id="17" name="TextBox 16"/>
           <p:cNvSpPr txBox="1"/>
           <p:nvPr/>
         </p:nvSpPr>
@@ -9927,7 +10071,7 @@
       </p:sp>
       <p:sp>
         <p:nvSpPr>
-          <p:cNvPr id="17" name="TextBox 16"/>
+          <p:cNvPr id="18" name="TextBox 17"/>
           <p:cNvSpPr txBox="1"/>
           <p:nvPr/>
         </p:nvSpPr>
@@ -9963,7 +10107,7 @@
       </p:sp>
       <p:sp>
         <p:nvSpPr>
-          <p:cNvPr id="18" name="Rounded Rectangle 17"/>
+          <p:cNvPr id="19" name="Rounded Rectangle 18"/>
           <p:cNvSpPr/>
           <p:nvPr/>
         </p:nvSpPr>
@@ -10008,7 +10152,7 @@
       </p:sp>
       <p:sp>
         <p:nvSpPr>
-          <p:cNvPr id="19" name="Rectangle 18"/>
+          <p:cNvPr id="20" name="Rectangle 19"/>
           <p:cNvSpPr/>
           <p:nvPr/>
         </p:nvSpPr>
@@ -10051,7 +10195,7 @@
       </p:sp>
       <p:sp>
         <p:nvSpPr>
-          <p:cNvPr id="20" name="TextBox 19"/>
+          <p:cNvPr id="21" name="TextBox 20"/>
           <p:cNvSpPr txBox="1"/>
           <p:nvPr/>
         </p:nvSpPr>
@@ -10087,7 +10231,7 @@
       </p:sp>
       <p:sp>
         <p:nvSpPr>
-          <p:cNvPr id="21" name="TextBox 20"/>
+          <p:cNvPr id="22" name="TextBox 21"/>
           <p:cNvSpPr txBox="1"/>
           <p:nvPr/>
         </p:nvSpPr>
@@ -10123,7 +10267,7 @@
       </p:sp>
       <p:sp>
         <p:nvSpPr>
-          <p:cNvPr id="22" name="Rounded Rectangle 21"/>
+          <p:cNvPr id="23" name="Rounded Rectangle 22"/>
           <p:cNvSpPr/>
           <p:nvPr/>
         </p:nvSpPr>
@@ -10168,7 +10312,7 @@
       </p:sp>
       <p:sp>
         <p:nvSpPr>
-          <p:cNvPr id="23" name="Rectangle 22"/>
+          <p:cNvPr id="24" name="Rectangle 23"/>
           <p:cNvSpPr/>
           <p:nvPr/>
         </p:nvSpPr>
@@ -10181,7 +10325,7 @@
             <a:avLst/>
           </a:prstGeom>
           <a:solidFill>
-            <a:srgbClr val="18A6A6"/>
+            <a:srgbClr val="18C2F2"/>
           </a:solidFill>
           <a:ln>
             <a:noFill/>
@@ -10211,7 +10355,7 @@
       </p:sp>
       <p:sp>
         <p:nvSpPr>
-          <p:cNvPr id="24" name="TextBox 23"/>
+          <p:cNvPr id="25" name="TextBox 24"/>
           <p:cNvSpPr txBox="1"/>
           <p:nvPr/>
         </p:nvSpPr>
@@ -10247,7 +10391,7 @@
       </p:sp>
       <p:sp>
         <p:nvSpPr>
-          <p:cNvPr id="25" name="TextBox 24"/>
+          <p:cNvPr id="26" name="TextBox 25"/>
           <p:cNvSpPr txBox="1"/>
           <p:nvPr/>
         </p:nvSpPr>
@@ -10332,7 +10476,7 @@
             <a:pPr algn="l">
               <a:defRPr sz="1000" b="1">
                 <a:solidFill>
-                  <a:srgbClr val="18A6A6"/>
+                  <a:srgbClr val="18C2F2"/>
                 </a:solidFill>
                 <a:latin typeface="Aptos"/>
               </a:defRPr>
@@ -10458,9 +10602,33 @@
           </a:p>
         </p:txBody>
       </p:sp>
-      <p:sp>
-        <p:nvSpPr>
-          <p:cNvPr id="6" name="Rounded Rectangle 5"/>
+      <p:pic>
+        <p:nvPicPr>
+          <p:cNvPr id="6" name="Picture 5" descr="logo-latin-re.png"/>
+          <p:cNvPicPr>
+            <a:picLocks noChangeAspect="1"/>
+          </p:cNvPicPr>
+          <p:nvPr/>
+        </p:nvPicPr>
+        <p:blipFill>
+          <a:blip r:embed="rId2"/>
+          <a:stretch>
+            <a:fillRect/>
+          </a:stretch>
+        </p:blipFill>
+        <p:spPr>
+          <a:xfrm>
+            <a:off x="10104120" y="118872"/>
+            <a:ext cx="868680" cy="539411"/>
+          </a:xfrm>
+          <a:prstGeom prst="rect">
+            <a:avLst/>
+          </a:prstGeom>
+        </p:spPr>
+      </p:pic>
+      <p:sp>
+        <p:nvSpPr>
+          <p:cNvPr id="7" name="Rounded Rectangle 6"/>
           <p:cNvSpPr/>
           <p:nvPr/>
         </p:nvSpPr>
@@ -10505,7 +10673,7 @@
       </p:sp>
       <p:sp>
         <p:nvSpPr>
-          <p:cNvPr id="7" name="Rectangle 6"/>
+          <p:cNvPr id="8" name="Rectangle 7"/>
           <p:cNvSpPr/>
           <p:nvPr/>
         </p:nvSpPr>
@@ -10548,7 +10716,7 @@
       </p:sp>
       <p:sp>
         <p:nvSpPr>
-          <p:cNvPr id="8" name="TextBox 7"/>
+          <p:cNvPr id="9" name="TextBox 8"/>
           <p:cNvSpPr txBox="1"/>
           <p:nvPr/>
         </p:nvSpPr>
@@ -10584,7 +10752,7 @@
       </p:sp>
       <p:sp>
         <p:nvSpPr>
-          <p:cNvPr id="9" name="TextBox 8"/>
+          <p:cNvPr id="10" name="TextBox 9"/>
           <p:cNvSpPr txBox="1"/>
           <p:nvPr/>
         </p:nvSpPr>
@@ -10636,7 +10804,7 @@
       </p:sp>
       <p:sp>
         <p:nvSpPr>
-          <p:cNvPr id="10" name="Rounded Rectangle 9"/>
+          <p:cNvPr id="11" name="Rounded Rectangle 10"/>
           <p:cNvSpPr/>
           <p:nvPr/>
         </p:nvSpPr>
@@ -10681,7 +10849,7 @@
       </p:sp>
       <p:sp>
         <p:nvSpPr>
-          <p:cNvPr id="11" name="Rectangle 10"/>
+          <p:cNvPr id="12" name="Rectangle 11"/>
           <p:cNvSpPr/>
           <p:nvPr/>
         </p:nvSpPr>
@@ -10694,7 +10862,7 @@
             <a:avLst/>
           </a:prstGeom>
           <a:solidFill>
-            <a:srgbClr val="18A6A6"/>
+            <a:srgbClr val="18C2F2"/>
           </a:solidFill>
           <a:ln>
             <a:noFill/>
@@ -10724,7 +10892,7 @@
       </p:sp>
       <p:sp>
         <p:nvSpPr>
-          <p:cNvPr id="12" name="TextBox 11"/>
+          <p:cNvPr id="13" name="TextBox 12"/>
           <p:cNvSpPr txBox="1"/>
           <p:nvPr/>
         </p:nvSpPr>
@@ -10760,7 +10928,7 @@
       </p:sp>
       <p:sp>
         <p:nvSpPr>
-          <p:cNvPr id="13" name="TextBox 12"/>
+          <p:cNvPr id="14" name="TextBox 13"/>
           <p:cNvSpPr txBox="1"/>
           <p:nvPr/>
         </p:nvSpPr>
@@ -10812,7 +10980,7 @@
       </p:sp>
       <p:sp>
         <p:nvSpPr>
-          <p:cNvPr id="14" name="Rounded Rectangle 13"/>
+          <p:cNvPr id="15" name="Rounded Rectangle 14"/>
           <p:cNvSpPr/>
           <p:nvPr/>
         </p:nvSpPr>
@@ -10857,7 +11025,7 @@
       </p:sp>
       <p:sp>
         <p:nvSpPr>
-          <p:cNvPr id="15" name="Rectangle 14"/>
+          <p:cNvPr id="16" name="Rectangle 15"/>
           <p:cNvSpPr/>
           <p:nvPr/>
         </p:nvSpPr>
@@ -10870,7 +11038,7 @@
             <a:avLst/>
           </a:prstGeom>
           <a:solidFill>
-            <a:srgbClr val="18A6A6"/>
+            <a:srgbClr val="18C2F2"/>
           </a:solidFill>
           <a:ln>
             <a:noFill/>
@@ -10900,7 +11068,7 @@
       </p:sp>
       <p:sp>
         <p:nvSpPr>
-          <p:cNvPr id="16" name="TextBox 15"/>
+          <p:cNvPr id="17" name="TextBox 16"/>
           <p:cNvSpPr txBox="1"/>
           <p:nvPr/>
         </p:nvSpPr>
@@ -10936,7 +11104,7 @@
       </p:sp>
       <p:sp>
         <p:nvSpPr>
-          <p:cNvPr id="17" name="TextBox 16"/>
+          <p:cNvPr id="18" name="TextBox 17"/>
           <p:cNvSpPr txBox="1"/>
           <p:nvPr/>
         </p:nvSpPr>
@@ -11224,7 +11392,7 @@
             <a:pPr algn="ctr">
               <a:defRPr sz="1600" b="1">
                 <a:solidFill>
-                  <a:srgbClr val="18A6A6"/>
+                  <a:srgbClr val="18C2F2"/>
                 </a:solidFill>
                 <a:latin typeface="Aptos"/>
               </a:defRPr>
@@ -11243,8 +11411,8 @@
         </p:nvSpPr>
         <p:spPr>
           <a:xfrm>
-            <a:off x="1188720" y="5806440"/>
-            <a:ext cx="9784080" cy="365760"/>
+            <a:off x="914400" y="5596128"/>
+            <a:ext cx="10332720" cy="310896"/>
           </a:xfrm>
           <a:prstGeom prst="rect">
             <a:avLst/>
@@ -11258,7 +11426,7 @@
           <a:lstStyle/>
           <a:p>
             <a:pPr algn="ctr">
-              <a:defRPr sz="1000" b="1">
+              <a:defRPr sz="900" b="1">
                 <a:solidFill>
                   <a:srgbClr val="FFFFFF"/>
                 </a:solidFill>
@@ -11266,7 +11434,43 @@
               </a:defRPr>
             </a:pPr>
             <a:r>
-              <a:t>EQUIPE: PREENCHER NOMES · REPOSITÓRIO: PREENCHER URL</a:t>
+              <a:t>GRUPO LATINTECH · Fábio Castro · Lucas Godois · Pedro Campos · Rogério Sousa · Fernando Gonçalves</a:t>
+            </a:r>
+          </a:p>
+        </p:txBody>
+      </p:sp>
+      <p:sp>
+        <p:nvSpPr>
+          <p:cNvPr id="9" name="TextBox 8"/>
+          <p:cNvSpPr txBox="1"/>
+          <p:nvPr/>
+        </p:nvSpPr>
+        <p:spPr>
+          <a:xfrm>
+            <a:off x="914400" y="5971032"/>
+            <a:ext cx="10332720" cy="274320"/>
+          </a:xfrm>
+          <a:prstGeom prst="rect">
+            <a:avLst/>
+          </a:prstGeom>
+          <a:noFill/>
+        </p:spPr>
+        <p:txBody>
+          <a:bodyPr wrap="square" anchor="t">
+            <a:spAutoFit/>
+          </a:bodyPr>
+          <a:lstStyle/>
+          <a:p>
+            <a:pPr algn="ctr">
+              <a:defRPr sz="900" b="1">
+                <a:solidFill>
+                  <a:srgbClr val="18C2F2"/>
+                </a:solidFill>
+                <a:latin typeface="Aptos"/>
+              </a:defRPr>
+            </a:pPr>
+            <a:r>
+              <a:t>github.com/RogerioSousa123/insurminds-projeto-final-latintech</a:t>
             </a:r>
           </a:p>
         </p:txBody>

</xml_diff>